<commit_message>
feat: integrate Pi runtime and visual slide QC
</commit_message>
<xml_diff>
--- a/packages/pptx-engine/tests/fixtures/01_standard_business.pptx
+++ b/packages/pptx-engine/tests/fixtures/01_standard_business.pptx
@@ -3307,6 +3307,14 @@
 <file path=ppt/slides/slide4.xml><?xml version="1.0" encoding="utf-8"?>
 <p:sld xmlns:a="http://schemas.openxmlformats.org/drawingml/2006/main" xmlns:p="http://schemas.openxmlformats.org/presentationml/2006/main" xmlns:r="http://schemas.openxmlformats.org/officeDocument/2006/relationships">
   <p:cSld>
+    <p:bg>
+      <p:bgPr>
+        <a:solidFill>
+          <a:srgbClr val="F5F7FA"/>
+        </a:solidFill>
+        <a:effectLst/>
+      </p:bgPr>
+    </p:bg>
     <p:spTree>
       <p:nvGrpSpPr>
         <p:cNvPr id="1" name=""/>
@@ -3324,12 +3332,24 @@
             <p:ph type="title"/>
           </p:nvPr>
         </p:nvSpPr>
-        <p:spPr/>
-        <p:txBody>
-          <a:bodyPr/>
-          <a:lstStyle/>
-          <a:p>
-            <a:r>
+        <p:spPr>
+          <a:xfrm>
+            <a:off x="914377" y="514350"/>
+            <a:ext cx="10362941" cy="647684"/>
+          </a:xfrm>
+        </p:spPr>
+        <p:txBody>
+          <a:bodyPr/>
+          <a:lstStyle/>
+          <a:p>
+            <a:r>
+              <a:rPr sz="3600" b="1">
+                <a:solidFill>
+                  <a:srgbClr val="17324D"/>
+                </a:solidFill>
+                <a:latin typeface="Arial"/>
+                <a:ea typeface="Arial"/>
+              </a:rPr>
               <a:t>Revenue by Region</a:t>
             </a:r>
           </a:p>
@@ -3344,14 +3364,14 @@
           <p:nvPr/>
         </p:nvGraphicFramePr>
         <p:xfrm>
-          <a:off x="914400" y="1828800"/>
-          <a:ext cx="10286400" cy="2286000"/>
+          <a:off x="914377" y="1990675"/>
+          <a:ext cx="10362941" cy="2952676"/>
         </p:xfrm>
         <a:graphic>
           <a:graphicData uri="http://schemas.openxmlformats.org/drawingml/2006/table">
             <a:tbl>
-              <a:tblPr firstRow="1" bandRow="1">
-                <a:tableStyleId>{5C22544A-7EE6-4342-B048-85BDC9FD1C3A}</a:tableStyleId>
+              <a:tblPr firstRow="1">
+                <a:tableStyleId>{A10FF1CE-0000-4000-9000-000000000003}</a:tableStyleId>
               </a:tblPr>
               <a:tblGrid>
                 <a:gridCol w="3428800"/>
@@ -3364,7 +3384,13 @@
                     <a:bodyPr/>
                     <a:lstStyle/>
                     <a:p>
+                      <a:pPr algn="ctr"/>
                       <a:r>
+                        <a:rPr sz="1800" b="1">
+                          <a:solidFill>
+                            <a:srgbClr val="FFFFFF"/>
+                          </a:solidFill>
+                        </a:rPr>
                         <a:t>Region</a:t>
                       </a:r>
                     </a:p>
@@ -3376,7 +3402,13 @@
                     <a:bodyPr/>
                     <a:lstStyle/>
                     <a:p>
+                      <a:pPr algn="ctr"/>
                       <a:r>
+                        <a:rPr sz="1800" b="1">
+                          <a:solidFill>
+                            <a:srgbClr val="FFFFFF"/>
+                          </a:solidFill>
+                        </a:rPr>
                         <a:t>Q3</a:t>
                       </a:r>
                     </a:p>
@@ -3388,7 +3420,13 @@
                     <a:bodyPr/>
                     <a:lstStyle/>
                     <a:p>
+                      <a:pPr algn="ctr"/>
                       <a:r>
+                        <a:rPr sz="1800" b="1">
+                          <a:solidFill>
+                            <a:srgbClr val="FFFFFF"/>
+                          </a:solidFill>
+                        </a:rPr>
                         <a:t>YoY</a:t>
                       </a:r>
                     </a:p>
@@ -3402,7 +3440,13 @@
                     <a:bodyPr/>
                     <a:lstStyle/>
                     <a:p>
+                      <a:pPr algn="ctr"/>
                       <a:r>
+                        <a:rPr sz="1800">
+                          <a:solidFill>
+                            <a:srgbClr val="17324D"/>
+                          </a:solidFill>
+                        </a:rPr>
                         <a:t>NA</a:t>
                       </a:r>
                     </a:p>
@@ -3414,7 +3458,13 @@
                     <a:bodyPr/>
                     <a:lstStyle/>
                     <a:p>
+                      <a:pPr algn="ctr"/>
                       <a:r>
+                        <a:rPr sz="2200" b="1">
+                          <a:solidFill>
+                            <a:srgbClr val="17324D"/>
+                          </a:solidFill>
+                        </a:rPr>
                         <a:t>$12.3M</a:t>
                       </a:r>
                     </a:p>
@@ -3426,7 +3476,13 @@
                     <a:bodyPr/>
                     <a:lstStyle/>
                     <a:p>
+                      <a:pPr algn="ctr"/>
                       <a:r>
+                        <a:rPr sz="2200" b="1">
+                          <a:solidFill>
+                            <a:srgbClr val="16865C"/>
+                          </a:solidFill>
+                        </a:rPr>
                         <a:t>+8%</a:t>
                       </a:r>
                     </a:p>
@@ -3440,7 +3496,13 @@
                     <a:bodyPr/>
                     <a:lstStyle/>
                     <a:p>
+                      <a:pPr algn="ctr"/>
                       <a:r>
+                        <a:rPr sz="1800">
+                          <a:solidFill>
+                            <a:srgbClr val="17324D"/>
+                          </a:solidFill>
+                        </a:rPr>
                         <a:t>EMEA</a:t>
                       </a:r>
                     </a:p>
@@ -3452,7 +3514,13 @@
                     <a:bodyPr/>
                     <a:lstStyle/>
                     <a:p>
+                      <a:pPr algn="ctr"/>
                       <a:r>
+                        <a:rPr sz="2200" b="1">
+                          <a:solidFill>
+                            <a:srgbClr val="17324D"/>
+                          </a:solidFill>
+                        </a:rPr>
                         <a:t>$7.1M</a:t>
                       </a:r>
                     </a:p>
@@ -3464,7 +3532,13 @@
                     <a:bodyPr/>
                     <a:lstStyle/>
                     <a:p>
+                      <a:pPr algn="ctr"/>
                       <a:r>
+                        <a:rPr sz="2200" b="1">
+                          <a:solidFill>
+                            <a:srgbClr val="16865C"/>
+                          </a:solidFill>
+                        </a:rPr>
                         <a:t>+12%</a:t>
                       </a:r>
                     </a:p>

</xml_diff>